<commit_message>
Regenerate premium PPT (20 slides)
Co-authored-by: Raj Shekhar <shekharaj0007@users.noreply.github.com>
</commit_message>
<xml_diff>
--- a/Lattice_EDM_Circularity_Premium_Presentation.pptx
+++ b/Lattice_EDM_Circularity_Premium_Presentation.pptx
@@ -25,7 +25,6 @@
     <p:sldId id="273" r:id="rId24"/>
     <p:sldId id="274" r:id="rId25"/>
     <p:sldId id="275" r:id="rId26"/>
-    <p:sldId id="276" r:id="rId27"/>
   </p:sldIdLst>
   <p:sldSz cx="12191695" cy="6858000" type="screen4x3"/>
   <p:notesSz cx="6858000" cy="9144000"/>
@@ -4304,7 +4303,7 @@
                 </a:solidFill>
                 <a:latin typeface="Calibri"/>
               </a:rPr>
-              <a:t>10  /  21</a:t>
+              <a:t>10  /  20</a:t>
             </a:r>
           </a:p>
         </p:txBody>
@@ -4586,7 +4585,7 @@
                 </a:solidFill>
                 <a:latin typeface="Calibri"/>
               </a:rPr>
-              <a:t>11  /  21</a:t>
+              <a:t>11  /  20</a:t>
             </a:r>
           </a:p>
         </p:txBody>
@@ -4984,7 +4983,7 @@
                 </a:solidFill>
                 <a:latin typeface="Calibri"/>
               </a:rPr>
-              <a:t>12  /  21</a:t>
+              <a:t>12  /  20</a:t>
             </a:r>
           </a:p>
         </p:txBody>
@@ -6002,7 +6001,7 @@
                 </a:solidFill>
                 <a:latin typeface="Calibri"/>
               </a:rPr>
-              <a:t>13  /  21</a:t>
+              <a:t>13  /  20</a:t>
             </a:r>
           </a:p>
         </p:txBody>
@@ -7452,7 +7451,7 @@
                 </a:solidFill>
                 <a:latin typeface="Calibri"/>
               </a:rPr>
-              <a:t>14  /  21</a:t>
+              <a:t>14  /  20</a:t>
             </a:r>
           </a:p>
         </p:txBody>
@@ -7919,7 +7918,7 @@
                 </a:solidFill>
                 <a:latin typeface="Calibri"/>
               </a:rPr>
-              <a:t>15  /  21</a:t>
+              <a:t>15  /  20</a:t>
             </a:r>
           </a:p>
         </p:txBody>
@@ -8225,7 +8224,7 @@
                 </a:solidFill>
                 <a:latin typeface="Calibri"/>
               </a:rPr>
-              <a:t>16  /  21</a:t>
+              <a:t>16  /  20</a:t>
             </a:r>
           </a:p>
         </p:txBody>
@@ -8611,7 +8610,7 @@
                 </a:solidFill>
                 <a:latin typeface="Calibri"/>
               </a:rPr>
-              <a:t>17  /  21</a:t>
+              <a:t>17  /  20</a:t>
             </a:r>
           </a:p>
         </p:txBody>
@@ -8941,7 +8940,7 @@
                 </a:solidFill>
                 <a:latin typeface="Calibri"/>
               </a:rPr>
-              <a:t>18  /  21</a:t>
+              <a:t>18  /  20</a:t>
             </a:r>
           </a:p>
         </p:txBody>
@@ -9531,7 +9530,7 @@
                 </a:solidFill>
                 <a:latin typeface="Calibri"/>
               </a:rPr>
-              <a:t>19  /  21</a:t>
+              <a:t>19  /  20</a:t>
             </a:r>
           </a:p>
         </p:txBody>
@@ -10981,7 +10980,7 @@
                 </a:solidFill>
                 <a:latin typeface="Calibri"/>
               </a:rPr>
-              <a:t>2  /  21</a:t>
+              <a:t>2  /  20</a:t>
             </a:r>
           </a:p>
         </p:txBody>
@@ -10995,896 +10994,6 @@
 </file>
 
 <file path=ppt/slides/slide20.xml><?xml version="1.0" encoding="utf-8"?>
-<p:sld xmlns:a="http://schemas.openxmlformats.org/drawingml/2006/main" xmlns:p="http://schemas.openxmlformats.org/presentationml/2006/main" xmlns:r="http://schemas.openxmlformats.org/officeDocument/2006/relationships">
-  <p:cSld>
-    <p:bg>
-      <p:bgPr>
-        <a:solidFill>
-          <a:srgbClr val="F7F4EF"/>
-        </a:solidFill>
-        <a:effectLst/>
-      </p:bgPr>
-    </p:bg>
-    <p:spTree>
-      <p:nvGrpSpPr>
-        <p:cNvPr id="1" name=""/>
-        <p:cNvGrpSpPr/>
-        <p:nvPr/>
-      </p:nvGrpSpPr>
-      <p:grpSpPr/>
-      <p:sp>
-        <p:nvSpPr>
-          <p:cNvPr id="2" name="Rectangle 1"/>
-          <p:cNvSpPr/>
-          <p:nvPr/>
-        </p:nvSpPr>
-        <p:spPr>
-          <a:xfrm>
-            <a:off x="0" y="0"/>
-            <a:ext cx="12191695" cy="960120"/>
-          </a:xfrm>
-          <a:prstGeom prst="rect">
-            <a:avLst/>
-          </a:prstGeom>
-          <a:solidFill>
-            <a:srgbClr val="0F1C2E"/>
-          </a:solidFill>
-          <a:ln>
-            <a:noFill/>
-          </a:ln>
-        </p:spPr>
-        <p:style>
-          <a:lnRef idx="1">
-            <a:schemeClr val="accent1"/>
-          </a:lnRef>
-          <a:fillRef idx="3">
-            <a:schemeClr val="accent1"/>
-          </a:fillRef>
-          <a:effectRef idx="2">
-            <a:schemeClr val="accent1"/>
-          </a:effectRef>
-          <a:fontRef idx="minor">
-            <a:schemeClr val="lt1"/>
-          </a:fontRef>
-        </p:style>
-        <p:txBody>
-          <a:bodyPr rtlCol="0" anchor="ctr"/>
-          <a:lstStyle/>
-          <a:p>
-            <a:pPr algn="ctr"/>
-          </a:p>
-        </p:txBody>
-      </p:sp>
-      <p:sp>
-        <p:nvSpPr>
-          <p:cNvPr id="3" name="Rectangle 2"/>
-          <p:cNvSpPr/>
-          <p:nvPr/>
-        </p:nvSpPr>
-        <p:spPr>
-          <a:xfrm>
-            <a:off x="0" y="960120"/>
-            <a:ext cx="12191695" cy="73152"/>
-          </a:xfrm>
-          <a:prstGeom prst="rect">
-            <a:avLst/>
-          </a:prstGeom>
-          <a:solidFill>
-            <a:srgbClr val="0E7C86"/>
-          </a:solidFill>
-          <a:ln>
-            <a:noFill/>
-          </a:ln>
-        </p:spPr>
-        <p:style>
-          <a:lnRef idx="1">
-            <a:schemeClr val="accent1"/>
-          </a:lnRef>
-          <a:fillRef idx="3">
-            <a:schemeClr val="accent1"/>
-          </a:fillRef>
-          <a:effectRef idx="2">
-            <a:schemeClr val="accent1"/>
-          </a:effectRef>
-          <a:fontRef idx="minor">
-            <a:schemeClr val="lt1"/>
-          </a:fontRef>
-        </p:style>
-        <p:txBody>
-          <a:bodyPr rtlCol="0" anchor="ctr"/>
-          <a:lstStyle/>
-          <a:p>
-            <a:pPr algn="ctr"/>
-          </a:p>
-        </p:txBody>
-      </p:sp>
-      <p:sp>
-        <p:nvSpPr>
-          <p:cNvPr id="4" name="TextBox 3"/>
-          <p:cNvSpPr txBox="1"/>
-          <p:nvPr/>
-        </p:nvSpPr>
-        <p:spPr>
-          <a:xfrm>
-            <a:off x="411480" y="201168"/>
-            <a:ext cx="11338560" cy="502920"/>
-          </a:xfrm>
-          <a:prstGeom prst="rect">
-            <a:avLst/>
-          </a:prstGeom>
-          <a:noFill/>
-        </p:spPr>
-        <p:txBody>
-          <a:bodyPr wrap="none">
-            <a:spAutoFit/>
-          </a:bodyPr>
-          <a:lstStyle/>
-          <a:p>
-            <a:r>
-              <a:rPr sz="2600" b="1">
-                <a:solidFill>
-                  <a:srgbClr val="FFFFFF"/>
-                </a:solidFill>
-                <a:latin typeface="Calibri"/>
-              </a:rPr>
-              <a:t>Conclusion &amp; Takeaways</a:t>
-            </a:r>
-          </a:p>
-        </p:txBody>
-      </p:sp>
-      <p:sp>
-        <p:nvSpPr>
-          <p:cNvPr id="5" name="Rounded Rectangle 4"/>
-          <p:cNvSpPr/>
-          <p:nvPr/>
-        </p:nvSpPr>
-        <p:spPr>
-          <a:xfrm>
-            <a:off x="457200" y="1234440"/>
-            <a:ext cx="11247120" cy="1097280"/>
-          </a:xfrm>
-          <a:prstGeom prst="roundRect">
-            <a:avLst>
-              <a:gd name="adj" fmla="val 8000"/>
-            </a:avLst>
-          </a:prstGeom>
-          <a:solidFill>
-            <a:srgbClr val="FFFFFF"/>
-          </a:solidFill>
-          <a:ln>
-            <a:noFill/>
-          </a:ln>
-        </p:spPr>
-        <p:style>
-          <a:lnRef idx="1">
-            <a:schemeClr val="accent1"/>
-          </a:lnRef>
-          <a:fillRef idx="3">
-            <a:schemeClr val="accent1"/>
-          </a:fillRef>
-          <a:effectRef idx="2">
-            <a:schemeClr val="accent1"/>
-          </a:effectRef>
-          <a:fontRef idx="minor">
-            <a:schemeClr val="lt1"/>
-          </a:fontRef>
-        </p:style>
-        <p:txBody>
-          <a:bodyPr rtlCol="0" anchor="ctr"/>
-          <a:lstStyle/>
-          <a:p>
-            <a:pPr algn="ctr"/>
-          </a:p>
-        </p:txBody>
-      </p:sp>
-      <p:sp>
-        <p:nvSpPr>
-          <p:cNvPr id="6" name="Rectangle 5"/>
-          <p:cNvSpPr/>
-          <p:nvPr/>
-        </p:nvSpPr>
-        <p:spPr>
-          <a:xfrm>
-            <a:off x="457200" y="1234440"/>
-            <a:ext cx="128016" cy="1097280"/>
-          </a:xfrm>
-          <a:prstGeom prst="rect">
-            <a:avLst/>
-          </a:prstGeom>
-          <a:solidFill>
-            <a:srgbClr val="0E7C86"/>
-          </a:solidFill>
-          <a:ln>
-            <a:noFill/>
-          </a:ln>
-        </p:spPr>
-        <p:style>
-          <a:lnRef idx="1">
-            <a:schemeClr val="accent1"/>
-          </a:lnRef>
-          <a:fillRef idx="3">
-            <a:schemeClr val="accent1"/>
-          </a:fillRef>
-          <a:effectRef idx="2">
-            <a:schemeClr val="accent1"/>
-          </a:effectRef>
-          <a:fontRef idx="minor">
-            <a:schemeClr val="lt1"/>
-          </a:fontRef>
-        </p:style>
-        <p:txBody>
-          <a:bodyPr rtlCol="0" anchor="ctr"/>
-          <a:lstStyle/>
-          <a:p>
-            <a:pPr algn="ctr"/>
-          </a:p>
-        </p:txBody>
-      </p:sp>
-      <p:sp>
-        <p:nvSpPr>
-          <p:cNvPr id="7" name="TextBox 6"/>
-          <p:cNvSpPr txBox="1"/>
-          <p:nvPr/>
-        </p:nvSpPr>
-        <p:spPr>
-          <a:xfrm>
-            <a:off x="822960" y="1417320"/>
-            <a:ext cx="10515600" cy="320040"/>
-          </a:xfrm>
-          <a:prstGeom prst="rect">
-            <a:avLst/>
-          </a:prstGeom>
-          <a:noFill/>
-        </p:spPr>
-        <p:txBody>
-          <a:bodyPr wrap="square">
-            <a:spAutoFit/>
-          </a:bodyPr>
-          <a:lstStyle/>
-          <a:p>
-            <a:pPr algn="l"/>
-            <a:r>
-              <a:rPr sz="1600" b="1">
-                <a:solidFill>
-                  <a:srgbClr val="0F1C2E"/>
-                </a:solidFill>
-                <a:latin typeface="Calibri"/>
-              </a:rPr>
-              <a:t>SEM first</a:t>
-            </a:r>
-          </a:p>
-        </p:txBody>
-      </p:sp>
-      <p:sp>
-        <p:nvSpPr>
-          <p:cNvPr id="8" name="TextBox 7"/>
-          <p:cNvSpPr txBox="1"/>
-          <p:nvPr/>
-        </p:nvSpPr>
-        <p:spPr>
-          <a:xfrm>
-            <a:off x="822960" y="1737360"/>
-            <a:ext cx="10515600" cy="411480"/>
-          </a:xfrm>
-          <a:prstGeom prst="rect">
-            <a:avLst/>
-          </a:prstGeom>
-          <a:noFill/>
-        </p:spPr>
-        <p:txBody>
-          <a:bodyPr wrap="square">
-            <a:spAutoFit/>
-          </a:bodyPr>
-          <a:lstStyle/>
-          <a:p>
-            <a:pPr algn="l"/>
-            <a:r>
-              <a:rPr sz="1400" b="0">
-                <a:solidFill>
-                  <a:srgbClr val="3D4F5F"/>
-                </a:solidFill>
-                <a:latin typeface="Calibri"/>
-              </a:rPr>
-              <a:t>Supporting-ring circularity — not hole deviation — is the success metric.</a:t>
-            </a:r>
-          </a:p>
-        </p:txBody>
-      </p:sp>
-      <p:sp>
-        <p:nvSpPr>
-          <p:cNvPr id="9" name="Rounded Rectangle 8"/>
-          <p:cNvSpPr/>
-          <p:nvPr/>
-        </p:nvSpPr>
-        <p:spPr>
-          <a:xfrm>
-            <a:off x="457200" y="2468880"/>
-            <a:ext cx="11247120" cy="1097280"/>
-          </a:xfrm>
-          <a:prstGeom prst="roundRect">
-            <a:avLst>
-              <a:gd name="adj" fmla="val 8000"/>
-            </a:avLst>
-          </a:prstGeom>
-          <a:solidFill>
-            <a:srgbClr val="FFFFFF"/>
-          </a:solidFill>
-          <a:ln>
-            <a:noFill/>
-          </a:ln>
-        </p:spPr>
-        <p:style>
-          <a:lnRef idx="1">
-            <a:schemeClr val="accent1"/>
-          </a:lnRef>
-          <a:fillRef idx="3">
-            <a:schemeClr val="accent1"/>
-          </a:fillRef>
-          <a:effectRef idx="2">
-            <a:schemeClr val="accent1"/>
-          </a:effectRef>
-          <a:fontRef idx="minor">
-            <a:schemeClr val="lt1"/>
-          </a:fontRef>
-        </p:style>
-        <p:txBody>
-          <a:bodyPr rtlCol="0" anchor="ctr"/>
-          <a:lstStyle/>
-          <a:p>
-            <a:pPr algn="ctr"/>
-          </a:p>
-        </p:txBody>
-      </p:sp>
-      <p:sp>
-        <p:nvSpPr>
-          <p:cNvPr id="10" name="Rectangle 9"/>
-          <p:cNvSpPr/>
-          <p:nvPr/>
-        </p:nvSpPr>
-        <p:spPr>
-          <a:xfrm>
-            <a:off x="457200" y="2468880"/>
-            <a:ext cx="128016" cy="1097280"/>
-          </a:xfrm>
-          <a:prstGeom prst="rect">
-            <a:avLst/>
-          </a:prstGeom>
-          <a:solidFill>
-            <a:srgbClr val="D97A0C"/>
-          </a:solidFill>
-          <a:ln>
-            <a:noFill/>
-          </a:ln>
-        </p:spPr>
-        <p:style>
-          <a:lnRef idx="1">
-            <a:schemeClr val="accent1"/>
-          </a:lnRef>
-          <a:fillRef idx="3">
-            <a:schemeClr val="accent1"/>
-          </a:fillRef>
-          <a:effectRef idx="2">
-            <a:schemeClr val="accent1"/>
-          </a:effectRef>
-          <a:fontRef idx="minor">
-            <a:schemeClr val="lt1"/>
-          </a:fontRef>
-        </p:style>
-        <p:txBody>
-          <a:bodyPr rtlCol="0" anchor="ctr"/>
-          <a:lstStyle/>
-          <a:p>
-            <a:pPr algn="ctr"/>
-          </a:p>
-        </p:txBody>
-      </p:sp>
-      <p:sp>
-        <p:nvSpPr>
-          <p:cNvPr id="11" name="TextBox 10"/>
-          <p:cNvSpPr txBox="1"/>
-          <p:nvPr/>
-        </p:nvSpPr>
-        <p:spPr>
-          <a:xfrm>
-            <a:off x="822960" y="2651760"/>
-            <a:ext cx="10515600" cy="320040"/>
-          </a:xfrm>
-          <a:prstGeom prst="rect">
-            <a:avLst/>
-          </a:prstGeom>
-          <a:noFill/>
-        </p:spPr>
-        <p:txBody>
-          <a:bodyPr wrap="square">
-            <a:spAutoFit/>
-          </a:bodyPr>
-          <a:lstStyle/>
-          <a:p>
-            <a:pPr algn="l"/>
-            <a:r>
-              <a:rPr sz="1600" b="1">
-                <a:solidFill>
-                  <a:srgbClr val="0F1C2E"/>
-                </a:solidFill>
-                <a:latin typeface="Calibri"/>
-              </a:rPr>
-              <a:t>Sparse → dense</a:t>
-            </a:r>
-          </a:p>
-        </p:txBody>
-      </p:sp>
-      <p:sp>
-        <p:nvSpPr>
-          <p:cNvPr id="12" name="TextBox 11"/>
-          <p:cNvSpPr txBox="1"/>
-          <p:nvPr/>
-        </p:nvSpPr>
-        <p:spPr>
-          <a:xfrm>
-            <a:off x="822960" y="2971800"/>
-            <a:ext cx="10515600" cy="411480"/>
-          </a:xfrm>
-          <a:prstGeom prst="rect">
-            <a:avLst/>
-          </a:prstGeom>
-          <a:noFill/>
-        </p:spPr>
-        <p:txBody>
-          <a:bodyPr wrap="square">
-            <a:spAutoFit/>
-          </a:bodyPr>
-          <a:lstStyle/>
-          <a:p>
-            <a:pPr algn="l"/>
-            <a:r>
-              <a:rPr sz="1400" b="0">
-                <a:solidFill>
-                  <a:srgbClr val="3D4F5F"/>
-                </a:solidFill>
-                <a:latin typeface="Calibri"/>
-              </a:rPr>
-              <a:t>16 runs expand via GP synthetics + geometry-risk spatial label replay.</a:t>
-            </a:r>
-          </a:p>
-        </p:txBody>
-      </p:sp>
-      <p:sp>
-        <p:nvSpPr>
-          <p:cNvPr id="13" name="Rounded Rectangle 12"/>
-          <p:cNvSpPr/>
-          <p:nvPr/>
-        </p:nvSpPr>
-        <p:spPr>
-          <a:xfrm>
-            <a:off x="457200" y="3703320"/>
-            <a:ext cx="11247120" cy="1097280"/>
-          </a:xfrm>
-          <a:prstGeom prst="roundRect">
-            <a:avLst>
-              <a:gd name="adj" fmla="val 8000"/>
-            </a:avLst>
-          </a:prstGeom>
-          <a:solidFill>
-            <a:srgbClr val="FFFFFF"/>
-          </a:solidFill>
-          <a:ln>
-            <a:noFill/>
-          </a:ln>
-        </p:spPr>
-        <p:style>
-          <a:lnRef idx="1">
-            <a:schemeClr val="accent1"/>
-          </a:lnRef>
-          <a:fillRef idx="3">
-            <a:schemeClr val="accent1"/>
-          </a:fillRef>
-          <a:effectRef idx="2">
-            <a:schemeClr val="accent1"/>
-          </a:effectRef>
-          <a:fontRef idx="minor">
-            <a:schemeClr val="lt1"/>
-          </a:fontRef>
-        </p:style>
-        <p:txBody>
-          <a:bodyPr rtlCol="0" anchor="ctr"/>
-          <a:lstStyle/>
-          <a:p>
-            <a:pPr algn="ctr"/>
-          </a:p>
-        </p:txBody>
-      </p:sp>
-      <p:sp>
-        <p:nvSpPr>
-          <p:cNvPr id="14" name="Rectangle 13"/>
-          <p:cNvSpPr/>
-          <p:nvPr/>
-        </p:nvSpPr>
-        <p:spPr>
-          <a:xfrm>
-            <a:off x="457200" y="3703320"/>
-            <a:ext cx="128016" cy="1097280"/>
-          </a:xfrm>
-          <a:prstGeom prst="rect">
-            <a:avLst/>
-          </a:prstGeom>
-          <a:solidFill>
-            <a:srgbClr val="0E7C86"/>
-          </a:solidFill>
-          <a:ln>
-            <a:noFill/>
-          </a:ln>
-        </p:spPr>
-        <p:style>
-          <a:lnRef idx="1">
-            <a:schemeClr val="accent1"/>
-          </a:lnRef>
-          <a:fillRef idx="3">
-            <a:schemeClr val="accent1"/>
-          </a:fillRef>
-          <a:effectRef idx="2">
-            <a:schemeClr val="accent1"/>
-          </a:effectRef>
-          <a:fontRef idx="minor">
-            <a:schemeClr val="lt1"/>
-          </a:fontRef>
-        </p:style>
-        <p:txBody>
-          <a:bodyPr rtlCol="0" anchor="ctr"/>
-          <a:lstStyle/>
-          <a:p>
-            <a:pPr algn="ctr"/>
-          </a:p>
-        </p:txBody>
-      </p:sp>
-      <p:sp>
-        <p:nvSpPr>
-          <p:cNvPr id="15" name="TextBox 14"/>
-          <p:cNvSpPr txBox="1"/>
-          <p:nvPr/>
-        </p:nvSpPr>
-        <p:spPr>
-          <a:xfrm>
-            <a:off x="822960" y="3886200"/>
-            <a:ext cx="10515600" cy="320040"/>
-          </a:xfrm>
-          <a:prstGeom prst="rect">
-            <a:avLst/>
-          </a:prstGeom>
-          <a:noFill/>
-        </p:spPr>
-        <p:txBody>
-          <a:bodyPr wrap="square">
-            <a:spAutoFit/>
-          </a:bodyPr>
-          <a:lstStyle/>
-          <a:p>
-            <a:pPr algn="l"/>
-            <a:r>
-              <a:rPr sz="1600" b="1">
-                <a:solidFill>
-                  <a:srgbClr val="0F1C2E"/>
-                </a:solidFill>
-                <a:latin typeface="Calibri"/>
-              </a:rPr>
-              <a:t>Any position</a:t>
-            </a:r>
-          </a:p>
-        </p:txBody>
-      </p:sp>
-      <p:sp>
-        <p:nvSpPr>
-          <p:cNvPr id="16" name="TextBox 15"/>
-          <p:cNvSpPr txBox="1"/>
-          <p:nvPr/>
-        </p:nvSpPr>
-        <p:spPr>
-          <a:xfrm>
-            <a:off x="822960" y="4206240"/>
-            <a:ext cx="10515600" cy="411480"/>
-          </a:xfrm>
-          <a:prstGeom prst="rect">
-            <a:avLst/>
-          </a:prstGeom>
-          <a:noFill/>
-        </p:spPr>
-        <p:txBody>
-          <a:bodyPr wrap="square">
-            <a:spAutoFit/>
-          </a:bodyPr>
-          <a:lstStyle/>
-          <a:p>
-            <a:pPr algn="l"/>
-            <a:r>
-              <a:rPr sz="1400" b="0">
-                <a:solidFill>
-                  <a:srgbClr val="3D4F5F"/>
-                </a:solidFill>
-                <a:latin typeface="Calibri"/>
-              </a:rPr>
-              <a:t>20-D EDM+geometry features + GBR + physics blend → ratio at any (x,y).</a:t>
-            </a:r>
-          </a:p>
-        </p:txBody>
-      </p:sp>
-      <p:sp>
-        <p:nvSpPr>
-          <p:cNvPr id="17" name="Rounded Rectangle 16"/>
-          <p:cNvSpPr/>
-          <p:nvPr/>
-        </p:nvSpPr>
-        <p:spPr>
-          <a:xfrm>
-            <a:off x="457200" y="4937760"/>
-            <a:ext cx="11247120" cy="1097280"/>
-          </a:xfrm>
-          <a:prstGeom prst="roundRect">
-            <a:avLst>
-              <a:gd name="adj" fmla="val 8000"/>
-            </a:avLst>
-          </a:prstGeom>
-          <a:solidFill>
-            <a:srgbClr val="FFFFFF"/>
-          </a:solidFill>
-          <a:ln>
-            <a:noFill/>
-          </a:ln>
-        </p:spPr>
-        <p:style>
-          <a:lnRef idx="1">
-            <a:schemeClr val="accent1"/>
-          </a:lnRef>
-          <a:fillRef idx="3">
-            <a:schemeClr val="accent1"/>
-          </a:fillRef>
-          <a:effectRef idx="2">
-            <a:schemeClr val="accent1"/>
-          </a:effectRef>
-          <a:fontRef idx="minor">
-            <a:schemeClr val="lt1"/>
-          </a:fontRef>
-        </p:style>
-        <p:txBody>
-          <a:bodyPr rtlCol="0" anchor="ctr"/>
-          <a:lstStyle/>
-          <a:p>
-            <a:pPr algn="ctr"/>
-          </a:p>
-        </p:txBody>
-      </p:sp>
-      <p:sp>
-        <p:nvSpPr>
-          <p:cNvPr id="18" name="Rectangle 17"/>
-          <p:cNvSpPr/>
-          <p:nvPr/>
-        </p:nvSpPr>
-        <p:spPr>
-          <a:xfrm>
-            <a:off x="457200" y="4937760"/>
-            <a:ext cx="128016" cy="1097280"/>
-          </a:xfrm>
-          <a:prstGeom prst="rect">
-            <a:avLst/>
-          </a:prstGeom>
-          <a:solidFill>
-            <a:srgbClr val="D97A0C"/>
-          </a:solidFill>
-          <a:ln>
-            <a:noFill/>
-          </a:ln>
-        </p:spPr>
-        <p:style>
-          <a:lnRef idx="1">
-            <a:schemeClr val="accent1"/>
-          </a:lnRef>
-          <a:fillRef idx="3">
-            <a:schemeClr val="accent1"/>
-          </a:fillRef>
-          <a:effectRef idx="2">
-            <a:schemeClr val="accent1"/>
-          </a:effectRef>
-          <a:fontRef idx="minor">
-            <a:schemeClr val="lt1"/>
-          </a:fontRef>
-        </p:style>
-        <p:txBody>
-          <a:bodyPr rtlCol="0" anchor="ctr"/>
-          <a:lstStyle/>
-          <a:p>
-            <a:pPr algn="ctr"/>
-          </a:p>
-        </p:txBody>
-      </p:sp>
-      <p:sp>
-        <p:nvSpPr>
-          <p:cNvPr id="19" name="TextBox 18"/>
-          <p:cNvSpPr txBox="1"/>
-          <p:nvPr/>
-        </p:nvSpPr>
-        <p:spPr>
-          <a:xfrm>
-            <a:off x="822960" y="5120640"/>
-            <a:ext cx="10515600" cy="320040"/>
-          </a:xfrm>
-          <a:prstGeom prst="rect">
-            <a:avLst/>
-          </a:prstGeom>
-          <a:noFill/>
-        </p:spPr>
-        <p:txBody>
-          <a:bodyPr wrap="square">
-            <a:spAutoFit/>
-          </a:bodyPr>
-          <a:lstStyle/>
-          <a:p>
-            <a:pPr algn="l"/>
-            <a:r>
-              <a:rPr sz="1600" b="1">
-                <a:solidFill>
-                  <a:srgbClr val="0F1C2E"/>
-                </a:solidFill>
-                <a:latin typeface="Calibri"/>
-              </a:rPr>
-              <a:t>LatticeFlow</a:t>
-            </a:r>
-          </a:p>
-        </p:txBody>
-      </p:sp>
-      <p:sp>
-        <p:nvSpPr>
-          <p:cNvPr id="20" name="TextBox 19"/>
-          <p:cNvSpPr txBox="1"/>
-          <p:nvPr/>
-        </p:nvSpPr>
-        <p:spPr>
-          <a:xfrm>
-            <a:off x="822960" y="5440680"/>
-            <a:ext cx="10515600" cy="411480"/>
-          </a:xfrm>
-          <a:prstGeom prst="rect">
-            <a:avLst/>
-          </a:prstGeom>
-          <a:noFill/>
-        </p:spPr>
-        <p:txBody>
-          <a:bodyPr wrap="square">
-            <a:spAutoFit/>
-          </a:bodyPr>
-          <a:lstStyle/>
-          <a:p>
-            <a:pPr algn="l"/>
-            <a:r>
-              <a:rPr sz="1400" b="0">
-                <a:solidFill>
-                  <a:srgbClr val="3D4F5F"/>
-                </a:solidFill>
-                <a:latin typeface="Calibri"/>
-              </a:rPr>
-              <a:t>Website turns the science into grid heatmaps, PASS/FAIL, reports, and guidance.</a:t>
-            </a:r>
-          </a:p>
-        </p:txBody>
-      </p:sp>
-      <p:sp>
-        <p:nvSpPr>
-          <p:cNvPr id="21" name="Rectangle 20"/>
-          <p:cNvSpPr/>
-          <p:nvPr/>
-        </p:nvSpPr>
-        <p:spPr>
-          <a:xfrm>
-            <a:off x="0" y="6537960"/>
-            <a:ext cx="12191695" cy="320040"/>
-          </a:xfrm>
-          <a:prstGeom prst="rect">
-            <a:avLst/>
-          </a:prstGeom>
-          <a:solidFill>
-            <a:srgbClr val="E8EEF2"/>
-          </a:solidFill>
-          <a:ln>
-            <a:noFill/>
-          </a:ln>
-        </p:spPr>
-        <p:style>
-          <a:lnRef idx="1">
-            <a:schemeClr val="accent1"/>
-          </a:lnRef>
-          <a:fillRef idx="3">
-            <a:schemeClr val="accent1"/>
-          </a:fillRef>
-          <a:effectRef idx="2">
-            <a:schemeClr val="accent1"/>
-          </a:effectRef>
-          <a:fontRef idx="minor">
-            <a:schemeClr val="lt1"/>
-          </a:fontRef>
-        </p:style>
-        <p:txBody>
-          <a:bodyPr rtlCol="0" anchor="ctr"/>
-          <a:lstStyle/>
-          <a:p>
-            <a:pPr algn="ctr"/>
-          </a:p>
-        </p:txBody>
-      </p:sp>
-      <p:sp>
-        <p:nvSpPr>
-          <p:cNvPr id="22" name="TextBox 21"/>
-          <p:cNvSpPr txBox="1"/>
-          <p:nvPr/>
-        </p:nvSpPr>
-        <p:spPr>
-          <a:xfrm>
-            <a:off x="365760" y="6565392"/>
-            <a:ext cx="7315200" cy="256032"/>
-          </a:xfrm>
-          <a:prstGeom prst="rect">
-            <a:avLst/>
-          </a:prstGeom>
-          <a:noFill/>
-        </p:spPr>
-        <p:txBody>
-          <a:bodyPr wrap="none">
-            <a:spAutoFit/>
-          </a:bodyPr>
-          <a:lstStyle/>
-          <a:p>
-            <a:r>
-              <a:rPr sz="1000" b="0">
-                <a:solidFill>
-                  <a:srgbClr val="3D4F5F"/>
-                </a:solidFill>
-                <a:latin typeface="Calibri"/>
-              </a:rPr>
-              <a:t>LatticeFlow  ·  EDM Circularity Research</a:t>
-            </a:r>
-          </a:p>
-        </p:txBody>
-      </p:sp>
-      <p:sp>
-        <p:nvSpPr>
-          <p:cNvPr id="23" name="TextBox 22"/>
-          <p:cNvSpPr txBox="1"/>
-          <p:nvPr/>
-        </p:nvSpPr>
-        <p:spPr>
-          <a:xfrm>
-            <a:off x="9601200" y="6565392"/>
-            <a:ext cx="2194560" cy="256032"/>
-          </a:xfrm>
-          <a:prstGeom prst="rect">
-            <a:avLst/>
-          </a:prstGeom>
-          <a:noFill/>
-        </p:spPr>
-        <p:txBody>
-          <a:bodyPr wrap="none">
-            <a:spAutoFit/>
-          </a:bodyPr>
-          <a:lstStyle/>
-          <a:p>
-            <a:pPr algn="r"/>
-            <a:r>
-              <a:rPr sz="1000" b="1">
-                <a:solidFill>
-                  <a:srgbClr val="3D4F5F"/>
-                </a:solidFill>
-                <a:latin typeface="Calibri"/>
-              </a:rPr>
-              <a:t>20  /  21</a:t>
-            </a:r>
-          </a:p>
-        </p:txBody>
-      </p:sp>
-    </p:spTree>
-  </p:cSld>
-  <p:clrMapOvr>
-    <a:masterClrMapping/>
-  </p:clrMapOvr>
-</p:sld>
-</file>
-
-<file path=ppt/slides/slide21.xml><?xml version="1.0" encoding="utf-8"?>
 <p:sld xmlns:a="http://schemas.openxmlformats.org/drawingml/2006/main" xmlns:p="http://schemas.openxmlformats.org/presentationml/2006/main" xmlns:r="http://schemas.openxmlformats.org/officeDocument/2006/relationships">
   <p:cSld>
     <p:bg>
@@ -11996,8 +11105,8 @@
         </p:nvSpPr>
         <p:spPr>
           <a:xfrm>
-            <a:off x="731520" y="2194560"/>
-            <a:ext cx="10698480" cy="914400"/>
+            <a:off x="640080" y="411480"/>
+            <a:ext cx="10972800" cy="457200"/>
           </a:xfrm>
           <a:prstGeom prst="rect">
             <a:avLst/>
@@ -12010,29 +11119,74 @@
           </a:bodyPr>
           <a:lstStyle/>
           <a:p>
+            <a:pPr algn="l"/>
+            <a:r>
+              <a:rPr sz="2800" b="1">
+                <a:solidFill>
+                  <a:srgbClr val="FFFFFF"/>
+                </a:solidFill>
+                <a:latin typeface="Calibri"/>
+              </a:rPr>
+              <a:t>Conclusion &amp; Thank You</a:t>
+            </a:r>
+          </a:p>
+        </p:txBody>
+      </p:sp>
+      <p:sp>
+        <p:nvSpPr>
+          <p:cNvPr id="5" name="Rounded Rectangle 4"/>
+          <p:cNvSpPr/>
+          <p:nvPr/>
+        </p:nvSpPr>
+        <p:spPr>
+          <a:xfrm>
+            <a:off x="640080" y="1188720"/>
+            <a:ext cx="10881360" cy="640080"/>
+          </a:xfrm>
+          <a:prstGeom prst="roundRect">
+            <a:avLst>
+              <a:gd name="adj" fmla="val 8000"/>
+            </a:avLst>
+          </a:prstGeom>
+          <a:solidFill>
+            <a:srgbClr val="14283E"/>
+          </a:solidFill>
+          <a:ln>
+            <a:noFill/>
+          </a:ln>
+        </p:spPr>
+        <p:style>
+          <a:lnRef idx="1">
+            <a:schemeClr val="accent1"/>
+          </a:lnRef>
+          <a:fillRef idx="3">
+            <a:schemeClr val="accent1"/>
+          </a:fillRef>
+          <a:effectRef idx="2">
+            <a:schemeClr val="accent1"/>
+          </a:effectRef>
+          <a:fontRef idx="minor">
+            <a:schemeClr val="lt1"/>
+          </a:fontRef>
+        </p:style>
+        <p:txBody>
+          <a:bodyPr rtlCol="0" anchor="ctr"/>
+          <a:lstStyle/>
+          <a:p>
             <a:pPr algn="ctr"/>
-            <a:r>
-              <a:rPr sz="4800" b="1">
-                <a:solidFill>
-                  <a:srgbClr val="FFFFFF"/>
-                </a:solidFill>
-                <a:latin typeface="Calibri"/>
-              </a:rPr>
-              <a:t>Thank You</a:t>
-            </a:r>
-          </a:p>
-        </p:txBody>
-      </p:sp>
-      <p:sp>
-        <p:nvSpPr>
-          <p:cNvPr id="5" name="TextBox 4"/>
+          </a:p>
+        </p:txBody>
+      </p:sp>
+      <p:sp>
+        <p:nvSpPr>
+          <p:cNvPr id="6" name="TextBox 5"/>
           <p:cNvSpPr txBox="1"/>
           <p:nvPr/>
         </p:nvSpPr>
         <p:spPr>
           <a:xfrm>
-            <a:off x="731520" y="3291840"/>
-            <a:ext cx="10698480" cy="548640"/>
+            <a:off x="914400" y="1353312"/>
+            <a:ext cx="10332720" cy="365760"/>
           </a:xfrm>
           <a:prstGeom prst="rect">
             <a:avLst/>
@@ -12045,29 +11199,74 @@
           </a:bodyPr>
           <a:lstStyle/>
           <a:p>
+            <a:pPr algn="l"/>
+            <a:r>
+              <a:rPr sz="1600" b="0">
+                <a:solidFill>
+                  <a:srgbClr val="FFFFFF"/>
+                </a:solidFill>
+                <a:latin typeface="Calibri"/>
+              </a:rPr>
+              <a:t>SEM first — supporting-ring circularity beats hole-deviation metrics</a:t>
+            </a:r>
+          </a:p>
+        </p:txBody>
+      </p:sp>
+      <p:sp>
+        <p:nvSpPr>
+          <p:cNvPr id="7" name="Rounded Rectangle 6"/>
+          <p:cNvSpPr/>
+          <p:nvPr/>
+        </p:nvSpPr>
+        <p:spPr>
+          <a:xfrm>
+            <a:off x="640080" y="1965960"/>
+            <a:ext cx="10881360" cy="640080"/>
+          </a:xfrm>
+          <a:prstGeom prst="roundRect">
+            <a:avLst>
+              <a:gd name="adj" fmla="val 8000"/>
+            </a:avLst>
+          </a:prstGeom>
+          <a:solidFill>
+            <a:srgbClr val="14283E"/>
+          </a:solidFill>
+          <a:ln>
+            <a:noFill/>
+          </a:ln>
+        </p:spPr>
+        <p:style>
+          <a:lnRef idx="1">
+            <a:schemeClr val="accent1"/>
+          </a:lnRef>
+          <a:fillRef idx="3">
+            <a:schemeClr val="accent1"/>
+          </a:fillRef>
+          <a:effectRef idx="2">
+            <a:schemeClr val="accent1"/>
+          </a:effectRef>
+          <a:fontRef idx="minor">
+            <a:schemeClr val="lt1"/>
+          </a:fontRef>
+        </p:style>
+        <p:txBody>
+          <a:bodyPr rtlCol="0" anchor="ctr"/>
+          <a:lstStyle/>
+          <a:p>
             <a:pPr algn="ctr"/>
-            <a:r>
-              <a:rPr sz="2200" b="0">
-                <a:solidFill>
-                  <a:srgbClr val="B8C7D4"/>
-                </a:solidFill>
-                <a:latin typeface="Calibri"/>
-              </a:rPr>
-              <a:t>Questions &amp; Discussion</a:t>
-            </a:r>
-          </a:p>
-        </p:txBody>
-      </p:sp>
-      <p:sp>
-        <p:nvSpPr>
-          <p:cNvPr id="6" name="TextBox 5"/>
+          </a:p>
+        </p:txBody>
+      </p:sp>
+      <p:sp>
+        <p:nvSpPr>
+          <p:cNvPr id="8" name="TextBox 7"/>
           <p:cNvSpPr txBox="1"/>
           <p:nvPr/>
         </p:nvSpPr>
         <p:spPr>
           <a:xfrm>
-            <a:off x="731520" y="4754880"/>
-            <a:ext cx="10698480" cy="731520"/>
+            <a:off x="914400" y="2130552"/>
+            <a:ext cx="10332720" cy="365760"/>
           </a:xfrm>
           <a:prstGeom prst="rect">
             <a:avLst/>
@@ -12080,15 +11279,245 @@
           </a:bodyPr>
           <a:lstStyle/>
           <a:p>
+            <a:pPr algn="l"/>
+            <a:r>
+              <a:rPr sz="1600" b="0">
+                <a:solidFill>
+                  <a:srgbClr val="FFFFFF"/>
+                </a:solidFill>
+                <a:latin typeface="Calibri"/>
+              </a:rPr>
+              <a:t>Sparse → dense — GP synthetics + geometry-risk spatial label replay</a:t>
+            </a:r>
+          </a:p>
+        </p:txBody>
+      </p:sp>
+      <p:sp>
+        <p:nvSpPr>
+          <p:cNvPr id="9" name="Rounded Rectangle 8"/>
+          <p:cNvSpPr/>
+          <p:nvPr/>
+        </p:nvSpPr>
+        <p:spPr>
+          <a:xfrm>
+            <a:off x="640080" y="2743200"/>
+            <a:ext cx="10881360" cy="640080"/>
+          </a:xfrm>
+          <a:prstGeom prst="roundRect">
+            <a:avLst>
+              <a:gd name="adj" fmla="val 8000"/>
+            </a:avLst>
+          </a:prstGeom>
+          <a:solidFill>
+            <a:srgbClr val="14283E"/>
+          </a:solidFill>
+          <a:ln>
+            <a:noFill/>
+          </a:ln>
+        </p:spPr>
+        <p:style>
+          <a:lnRef idx="1">
+            <a:schemeClr val="accent1"/>
+          </a:lnRef>
+          <a:fillRef idx="3">
+            <a:schemeClr val="accent1"/>
+          </a:fillRef>
+          <a:effectRef idx="2">
+            <a:schemeClr val="accent1"/>
+          </a:effectRef>
+          <a:fontRef idx="minor">
+            <a:schemeClr val="lt1"/>
+          </a:fontRef>
+        </p:style>
+        <p:txBody>
+          <a:bodyPr rtlCol="0" anchor="ctr"/>
+          <a:lstStyle/>
+          <a:p>
             <a:pPr algn="ctr"/>
-            <a:r>
-              <a:rPr sz="1400" b="0">
+          </a:p>
+        </p:txBody>
+      </p:sp>
+      <p:sp>
+        <p:nvSpPr>
+          <p:cNvPr id="10" name="TextBox 9"/>
+          <p:cNvSpPr txBox="1"/>
+          <p:nvPr/>
+        </p:nvSpPr>
+        <p:spPr>
+          <a:xfrm>
+            <a:off x="914400" y="2907792"/>
+            <a:ext cx="10332720" cy="365760"/>
+          </a:xfrm>
+          <a:prstGeom prst="rect">
+            <a:avLst/>
+          </a:prstGeom>
+          <a:noFill/>
+        </p:spPr>
+        <p:txBody>
+          <a:bodyPr wrap="square">
+            <a:spAutoFit/>
+          </a:bodyPr>
+          <a:lstStyle/>
+          <a:p>
+            <a:pPr algn="l"/>
+            <a:r>
+              <a:rPr sz="1600" b="0">
+                <a:solidFill>
+                  <a:srgbClr val="FFFFFF"/>
+                </a:solidFill>
+                <a:latin typeface="Calibri"/>
+              </a:rPr>
+              <a:t>Any position — 20-D features + GBR + physics blend → ratio at any (x,y)</a:t>
+            </a:r>
+          </a:p>
+        </p:txBody>
+      </p:sp>
+      <p:sp>
+        <p:nvSpPr>
+          <p:cNvPr id="11" name="Rounded Rectangle 10"/>
+          <p:cNvSpPr/>
+          <p:nvPr/>
+        </p:nvSpPr>
+        <p:spPr>
+          <a:xfrm>
+            <a:off x="640080" y="3520439"/>
+            <a:ext cx="10881360" cy="640080"/>
+          </a:xfrm>
+          <a:prstGeom prst="roundRect">
+            <a:avLst>
+              <a:gd name="adj" fmla="val 8000"/>
+            </a:avLst>
+          </a:prstGeom>
+          <a:solidFill>
+            <a:srgbClr val="14283E"/>
+          </a:solidFill>
+          <a:ln>
+            <a:noFill/>
+          </a:ln>
+        </p:spPr>
+        <p:style>
+          <a:lnRef idx="1">
+            <a:schemeClr val="accent1"/>
+          </a:lnRef>
+          <a:fillRef idx="3">
+            <a:schemeClr val="accent1"/>
+          </a:fillRef>
+          <a:effectRef idx="2">
+            <a:schemeClr val="accent1"/>
+          </a:effectRef>
+          <a:fontRef idx="minor">
+            <a:schemeClr val="lt1"/>
+          </a:fontRef>
+        </p:style>
+        <p:txBody>
+          <a:bodyPr rtlCol="0" anchor="ctr"/>
+          <a:lstStyle/>
+          <a:p>
+            <a:pPr algn="ctr"/>
+          </a:p>
+        </p:txBody>
+      </p:sp>
+      <p:sp>
+        <p:nvSpPr>
+          <p:cNvPr id="12" name="TextBox 11"/>
+          <p:cNvSpPr txBox="1"/>
+          <p:nvPr/>
+        </p:nvSpPr>
+        <p:spPr>
+          <a:xfrm>
+            <a:off x="914400" y="3685031"/>
+            <a:ext cx="10332720" cy="365760"/>
+          </a:xfrm>
+          <a:prstGeom prst="rect">
+            <a:avLst/>
+          </a:prstGeom>
+          <a:noFill/>
+        </p:spPr>
+        <p:txBody>
+          <a:bodyPr wrap="square">
+            <a:spAutoFit/>
+          </a:bodyPr>
+          <a:lstStyle/>
+          <a:p>
+            <a:pPr algn="l"/>
+            <a:r>
+              <a:rPr sz="1600" b="0">
+                <a:solidFill>
+                  <a:srgbClr val="FFFFFF"/>
+                </a:solidFill>
+                <a:latin typeface="Calibri"/>
+              </a:rPr>
+              <a:t>LatticeFlow — heatmaps, PASS/FAIL, reports, and AI guidance in one tool</a:t>
+            </a:r>
+          </a:p>
+        </p:txBody>
+      </p:sp>
+      <p:sp>
+        <p:nvSpPr>
+          <p:cNvPr id="13" name="TextBox 12"/>
+          <p:cNvSpPr txBox="1"/>
+          <p:nvPr/>
+        </p:nvSpPr>
+        <p:spPr>
+          <a:xfrm>
+            <a:off x="640080" y="4572000"/>
+            <a:ext cx="10881360" cy="457200"/>
+          </a:xfrm>
+          <a:prstGeom prst="rect">
+            <a:avLst/>
+          </a:prstGeom>
+          <a:noFill/>
+        </p:spPr>
+        <p:txBody>
+          <a:bodyPr wrap="square">
+            <a:spAutoFit/>
+          </a:bodyPr>
+          <a:lstStyle/>
+          <a:p>
+            <a:pPr algn="ctr"/>
+            <a:r>
+              <a:rPr sz="2200" b="1">
+                <a:solidFill>
+                  <a:srgbClr val="0E7C86"/>
+                </a:solidFill>
+                <a:latin typeface="Calibri"/>
+              </a:rPr>
+              <a:t>Questions &amp; Discussion</a:t>
+            </a:r>
+          </a:p>
+        </p:txBody>
+      </p:sp>
+      <p:sp>
+        <p:nvSpPr>
+          <p:cNvPr id="14" name="TextBox 13"/>
+          <p:cNvSpPr txBox="1"/>
+          <p:nvPr/>
+        </p:nvSpPr>
+        <p:spPr>
+          <a:xfrm>
+            <a:off x="640080" y="5212080"/>
+            <a:ext cx="10881360" cy="731520"/>
+          </a:xfrm>
+          <a:prstGeom prst="rect">
+            <a:avLst/>
+          </a:prstGeom>
+          <a:noFill/>
+        </p:spPr>
+        <p:txBody>
+          <a:bodyPr wrap="square">
+            <a:spAutoFit/>
+          </a:bodyPr>
+          <a:lstStyle/>
+          <a:p>
+            <a:pPr algn="ctr"/>
+            <a:r>
+              <a:rPr sz="1300" b="0">
                 <a:solidFill>
                   <a:srgbClr val="8AA0B2"/>
                 </a:solidFill>
                 <a:latin typeface="Calibri"/>
               </a:rPr>
-              <a:t>PDF research paper + this deck available in the project repository
+              <a:t>PDF research paper + presentation decks are in the project repository
 Lattice Circularity Analyzer  ·  LatticeFlow</a:t>
             </a:r>
           </a:p>
@@ -12663,7 +12092,7 @@
                 </a:solidFill>
                 <a:latin typeface="Calibri"/>
               </a:rPr>
-              <a:t>3  /  21</a:t>
+              <a:t>3  /  20</a:t>
             </a:r>
           </a:p>
         </p:txBody>
@@ -13221,7 +12650,7 @@
                 </a:solidFill>
                 <a:latin typeface="Calibri"/>
               </a:rPr>
-              <a:t>4  /  21</a:t>
+              <a:t>4  /  20</a:t>
             </a:r>
           </a:p>
         </p:txBody>
@@ -13641,7 +13070,7 @@
                 </a:solidFill>
                 <a:latin typeface="Calibri"/>
               </a:rPr>
-              <a:t>5  /  21</a:t>
+              <a:t>5  /  20</a:t>
             </a:r>
           </a:p>
         </p:txBody>
@@ -13947,7 +13376,7 @@
                 </a:solidFill>
                 <a:latin typeface="Calibri"/>
               </a:rPr>
-              <a:t>6  /  21</a:t>
+              <a:t>6  /  20</a:t>
             </a:r>
           </a:p>
         </p:txBody>
@@ -14287,7 +13716,7 @@
                 </a:solidFill>
                 <a:latin typeface="Calibri"/>
               </a:rPr>
-              <a:t>7  /  21</a:t>
+              <a:t>7  /  20</a:t>
             </a:r>
           </a:p>
         </p:txBody>
@@ -14627,7 +14056,7 @@
                 </a:solidFill>
                 <a:latin typeface="Calibri"/>
               </a:rPr>
-              <a:t>8  /  21</a:t>
+              <a:t>8  /  20</a:t>
             </a:r>
           </a:p>
         </p:txBody>
@@ -14957,7 +14386,7 @@
                 </a:solidFill>
                 <a:latin typeface="Calibri"/>
               </a:rPr>
-              <a:t>9  /  21</a:t>
+              <a:t>9  /  20</a:t>
             </a:r>
           </a:p>
         </p:txBody>

</xml_diff>